<commit_message>
wire real names into deck + README team section
Meet Gajjar — Data · Agent · Fine-Tune (slides 6–9, the LLM core)
Aashish Patel — Product · Opening (slides 3–5, problem + happy-path demo)
Daksh Gupta — Pipeline · Matching (slides 10–13, scoring + LLM expansion)
</commit_message>
<xml_diff>
--- a/CureMatch_Presentation.pptx
+++ b/CureMatch_Presentation.pptx
@@ -3340,13 +3340,13 @@
               </a:lnSpc>
             </a:pPr>
             <a:r>
-              <a:rPr sz="1300" b="0" i="0">
-                <a:solidFill>
-                  <a:srgbClr val="86868B"/>
+              <a:rPr sz="1400" b="1" i="0">
+                <a:solidFill>
+                  <a:srgbClr val="3B3B41"/>
                 </a:solidFill>
                 <a:latin typeface="JetBrains Mono"/>
               </a:rPr>
-              <a:t>[Person A]  ·  [Person B]  ·  [Person C]</a:t>
+              <a:t>Meet Gajjar  ·  Aashish Patel  ·  Daksh Gupta</a:t>
             </a:r>
           </a:p>
         </p:txBody>
@@ -3535,7 +3535,7 @@
                 </a:solidFill>
                 <a:latin typeface="Helvetica Neue"/>
               </a:rPr>
-              <a:t>PERSON C</a:t>
+              <a:t>DAKSH GUPTA</a:t>
             </a:r>
           </a:p>
         </p:txBody>
@@ -3983,7 +3983,7 @@
                 </a:solidFill>
                 <a:latin typeface="Helvetica Neue"/>
               </a:rPr>
-              <a:t>PERSON C</a:t>
+              <a:t>DAKSH GUPTA</a:t>
             </a:r>
           </a:p>
         </p:txBody>
@@ -5211,7 +5211,7 @@
                 </a:solidFill>
                 <a:latin typeface="Helvetica Neue"/>
               </a:rPr>
-              <a:t>PERSON C</a:t>
+              <a:t>DAKSH GUPTA</a:t>
             </a:r>
           </a:p>
         </p:txBody>
@@ -6015,7 +6015,7 @@
                 </a:solidFill>
                 <a:latin typeface="Helvetica Neue"/>
               </a:rPr>
-              <a:t>PERSON C</a:t>
+              <a:t>DAKSH GUPTA</a:t>
             </a:r>
           </a:p>
         </p:txBody>
@@ -8791,7 +8791,7 @@
                 </a:solidFill>
                 <a:latin typeface="Helvetica Neue"/>
               </a:rPr>
-              <a:t>Person A</a:t>
+              <a:t>Aashish Patel</a:t>
             </a:r>
           </a:p>
         </p:txBody>
@@ -8830,7 +8830,7 @@
                 </a:solidFill>
                 <a:latin typeface="Helvetica Neue"/>
               </a:rPr>
-              <a:t>Product · Chat Agent</a:t>
+              <a:t>Product · Opening</a:t>
             </a:r>
           </a:p>
         </p:txBody>
@@ -8869,7 +8869,7 @@
                 </a:solidFill>
                 <a:latin typeface="Helvetica Neue"/>
               </a:rPr>
-              <a:t>Built the patient-facing chat agent and the match explainer. RAG grounding, streaming, refusal behavior.</a:t>
+              <a:t>Opens the talk — the problem, what we built, and the happy-path demo. Walks through profile intake and the match explainer narrating verdicts live.</a:t>
             </a:r>
           </a:p>
         </p:txBody>
@@ -9000,7 +9000,7 @@
                 </a:solidFill>
                 <a:latin typeface="Helvetica Neue"/>
               </a:rPr>
-              <a:t>Person B</a:t>
+              <a:t>Meet Gajjar</a:t>
             </a:r>
           </a:p>
         </p:txBody>
@@ -9039,7 +9039,7 @@
                 </a:solidFill>
                 <a:latin typeface="Helvetica Neue"/>
               </a:rPr>
-              <a:t>Data · Fine-Tune</a:t>
+              <a:t>Data · Agent · Fine-Tune</a:t>
             </a:r>
           </a:p>
         </p:txBody>
@@ -9078,7 +9078,7 @@
                 </a:solidFill>
                 <a:latin typeface="Helvetica Neue"/>
               </a:rPr>
-              <a:t>Built the 450-pair Q&amp;A dataset, trained a LoRA adapter on Llama 3.2 1B, evaluated before/after refusal.</a:t>
+              <a:t>The LLM layer end-to-end. The 65,081-trial corpus, the rule parser's 33% coverage, the LoRA fine-tune on Llama 3.2 1B, and the live chat agent demo.</a:t>
             </a:r>
           </a:p>
         </p:txBody>
@@ -9209,7 +9209,7 @@
                 </a:solidFill>
                 <a:latin typeface="Helvetica Neue"/>
               </a:rPr>
-              <a:t>Person C</a:t>
+              <a:t>Daksh Gupta</a:t>
             </a:r>
           </a:p>
         </p:txBody>
@@ -9287,7 +9287,7 @@
                 </a:solidFill>
                 <a:latin typeface="Helvetica Neue"/>
               </a:rPr>
-              <a:t>Built the rule-based parser, the deterministic scoring engine, and the condition-disambiguation that prevents false matches.</a:t>
+              <a:t>Why rules decide the match, not the LLM. The six-criterion scoring engine and where LLMs expand matching — compound criteria, negation, paraphrase.</a:t>
             </a:r>
           </a:p>
         </p:txBody>
@@ -9476,7 +9476,7 @@
                 </a:solidFill>
                 <a:latin typeface="Helvetica Neue"/>
               </a:rPr>
-              <a:t>PERSON A</a:t>
+              <a:t>AASHISH PATEL</a:t>
             </a:r>
           </a:p>
         </p:txBody>
@@ -9924,7 +9924,7 @@
                 </a:solidFill>
                 <a:latin typeface="Helvetica Neue"/>
               </a:rPr>
-              <a:t>PERSON A</a:t>
+              <a:t>AASHISH PATEL</a:t>
             </a:r>
           </a:p>
         </p:txBody>
@@ -10725,7 +10725,7 @@
                 </a:solidFill>
                 <a:latin typeface="Helvetica Neue"/>
               </a:rPr>
-              <a:t>PERSON A</a:t>
+              <a:t>AASHISH PATEL</a:t>
             </a:r>
           </a:p>
         </p:txBody>
@@ -11155,7 +11155,7 @@
                 </a:solidFill>
                 <a:latin typeface="Helvetica Neue"/>
               </a:rPr>
-              <a:t>PERSON B</a:t>
+              <a:t>MEET GAJJAR</a:t>
             </a:r>
           </a:p>
         </p:txBody>
@@ -11509,7 +11509,7 @@
                 </a:solidFill>
                 <a:latin typeface="Helvetica Neue"/>
               </a:rPr>
-              <a:t>PERSON B</a:t>
+              <a:t>MEET GAJJAR</a:t>
             </a:r>
           </a:p>
         </p:txBody>
@@ -11839,7 +11839,7 @@
                 </a:solidFill>
                 <a:latin typeface="Helvetica Neue"/>
               </a:rPr>
-              <a:t>PERSON B</a:t>
+              <a:t>MEET GAJJAR</a:t>
             </a:r>
           </a:p>
         </p:txBody>
@@ -12752,7 +12752,7 @@
                 </a:solidFill>
                 <a:latin typeface="Helvetica Neue"/>
               </a:rPr>
-              <a:t>PERSON B</a:t>
+              <a:t>MEET GAJJAR</a:t>
             </a:r>
           </a:p>
         </p:txBody>

</xml_diff>

<commit_message>
fix deck layout — team card overflow, chat agent overlap, prompt width
Renders cleanly end-to-end now: verified by PowerPoint → PDF → PNG.

  slide 5:  team cards resized 3.65" tall, tightened copy
  slide 7:  prompt box centered + narrowed from 9.5" to 7.55"
  slide 9:  left card up to 4.15" tall, right steps spaced 0.66" apart
</commit_message>
<xml_diff>
--- a/CureMatch_Presentation.pptx
+++ b/CureMatch_Presentation.pptx
@@ -10242,7 +10242,7 @@
         <p:spPr>
           <a:xfrm>
             <a:off x="548640" y="1005840"/>
-            <a:ext cx="8656624" cy="1920240"/>
+            <a:ext cx="8656624" cy="914400"/>
           </a:xfrm>
           <a:prstGeom prst="rect">
             <a:avLst/>
@@ -10261,43 +10261,66 @@
               </a:lnSpc>
             </a:pPr>
             <a:r>
-              <a:rPr sz="4400" b="1" i="0" spc="-26">
+              <a:rPr sz="3800" b="1" i="0" spc="-24">
                 <a:solidFill>
                   <a:srgbClr val="1D1D1F"/>
                 </a:solidFill>
                 <a:latin typeface="Helvetica Neue"/>
               </a:rPr>
-              <a:t>Three engineers.</a:t>
-            </a:r>
-          </a:p>
-          <a:p>
-            <a:pPr algn="l">
-              <a:lnSpc>
-                <a:spcPct val="105000"/>
-              </a:lnSpc>
-            </a:pPr>
-            <a:r>
-              <a:rPr sz="4400" b="1" i="0" spc="-26">
-                <a:solidFill>
-                  <a:srgbClr val="1D1D1F"/>
-                </a:solidFill>
-                <a:latin typeface="Helvetica Neue"/>
-              </a:rPr>
-              <a:t>Three language models.</a:t>
-            </a:r>
-          </a:p>
-        </p:txBody>
-      </p:sp>
-      <p:sp>
-        <p:nvSpPr>
-          <p:cNvPr id="4" name="Rounded Rectangle 3"/>
+              <a:t>Three engineers. Three LLMs.</a:t>
+            </a:r>
+          </a:p>
+        </p:txBody>
+      </p:sp>
+      <p:sp>
+        <p:nvSpPr>
+          <p:cNvPr id="4" name="TextBox 3"/>
+          <p:cNvSpPr txBox="1"/>
+          <p:nvPr/>
+        </p:nvSpPr>
+        <p:spPr>
+          <a:xfrm>
+            <a:off x="548640" y="1965960"/>
+            <a:ext cx="9144000" cy="457200"/>
+          </a:xfrm>
+          <a:prstGeom prst="rect">
+            <a:avLst/>
+          </a:prstGeom>
+          <a:noFill/>
+        </p:spPr>
+        <p:txBody>
+          <a:bodyPr wrap="square" lIns="0" rIns="0" tIns="0" bIns="0" anchor="t">
+            <a:spAutoFit/>
+          </a:bodyPr>
+          <a:lstStyle/>
+          <a:p>
+            <a:pPr algn="l">
+              <a:lnSpc>
+                <a:spcPct val="120000"/>
+              </a:lnSpc>
+            </a:pPr>
+            <a:r>
+              <a:rPr sz="1500" b="0" i="0">
+                <a:solidFill>
+                  <a:srgbClr val="6E6E73"/>
+                </a:solidFill>
+                <a:latin typeface="Helvetica Neue"/>
+              </a:rPr>
+              <a:t>Each of us built a distinct language model into the product.</a:t>
+            </a:r>
+          </a:p>
+        </p:txBody>
+      </p:sp>
+      <p:sp>
+        <p:nvSpPr>
+          <p:cNvPr id="5" name="Rounded Rectangle 4"/>
           <p:cNvSpPr/>
           <p:nvPr/>
         </p:nvSpPr>
         <p:spPr>
           <a:xfrm>
-            <a:off x="548640" y="3931920"/>
-            <a:ext cx="2834640" cy="2560320"/>
+            <a:off x="548640" y="2834640"/>
+            <a:ext cx="2834640" cy="3337560"/>
           </a:xfrm>
           <a:prstGeom prst="roundRect">
             <a:avLst>
@@ -10338,13 +10361,13 @@
       </p:sp>
       <p:sp>
         <p:nvSpPr>
-          <p:cNvPr id="5" name="TextBox 4"/>
-          <p:cNvSpPr txBox="1"/>
-          <p:nvPr/>
-        </p:nvSpPr>
-        <p:spPr>
-          <a:xfrm>
-            <a:off x="822959" y="4160520"/>
+          <p:cNvPr id="6" name="TextBox 5"/>
+          <p:cNvSpPr txBox="1"/>
+          <p:nvPr/>
+        </p:nvSpPr>
+        <p:spPr>
+          <a:xfrm>
+            <a:off x="822959" y="3108960"/>
             <a:ext cx="2286000" cy="320040"/>
           </a:xfrm>
           <a:prstGeom prst="rect">
@@ -10377,13 +10400,13 @@
       </p:sp>
       <p:sp>
         <p:nvSpPr>
-          <p:cNvPr id="6" name="TextBox 5"/>
-          <p:cNvSpPr txBox="1"/>
-          <p:nvPr/>
-        </p:nvSpPr>
-        <p:spPr>
-          <a:xfrm>
-            <a:off x="822959" y="4498848"/>
+          <p:cNvPr id="7" name="TextBox 6"/>
+          <p:cNvSpPr txBox="1"/>
+          <p:nvPr/>
+        </p:nvSpPr>
+        <p:spPr>
+          <a:xfrm>
+            <a:off x="822959" y="3474720"/>
             <a:ext cx="2286000" cy="502920"/>
           </a:xfrm>
           <a:prstGeom prst="rect">
@@ -10403,7 +10426,7 @@
               </a:lnSpc>
             </a:pPr>
             <a:r>
-              <a:rPr sz="1800" b="1" i="0" spc="-10">
+              <a:rPr sz="1900" b="1" i="0" spc="-10">
                 <a:solidFill>
                   <a:srgbClr val="1D1D1F"/>
                 </a:solidFill>
@@ -10416,29 +10439,29 @@
       </p:sp>
       <p:sp>
         <p:nvSpPr>
-          <p:cNvPr id="7" name="TextBox 6"/>
-          <p:cNvSpPr txBox="1"/>
-          <p:nvPr/>
-        </p:nvSpPr>
-        <p:spPr>
-          <a:xfrm>
-            <a:off x="822959" y="5010912"/>
-            <a:ext cx="2286000" cy="411480"/>
-          </a:xfrm>
-          <a:prstGeom prst="rect">
-            <a:avLst/>
-          </a:prstGeom>
-          <a:noFill/>
-        </p:spPr>
-        <p:txBody>
-          <a:bodyPr wrap="square" lIns="0" rIns="0" tIns="0" bIns="0" anchor="t">
-            <a:spAutoFit/>
-          </a:bodyPr>
-          <a:lstStyle/>
-          <a:p>
-            <a:pPr algn="l">
-              <a:lnSpc>
-                <a:spcPct val="120000"/>
+          <p:cNvPr id="8" name="TextBox 7"/>
+          <p:cNvSpPr txBox="1"/>
+          <p:nvPr/>
+        </p:nvSpPr>
+        <p:spPr>
+          <a:xfrm>
+            <a:off x="822959" y="4041648"/>
+            <a:ext cx="2286000" cy="731520"/>
+          </a:xfrm>
+          <a:prstGeom prst="rect">
+            <a:avLst/>
+          </a:prstGeom>
+          <a:noFill/>
+        </p:spPr>
+        <p:txBody>
+          <a:bodyPr wrap="square" lIns="0" rIns="0" tIns="0" bIns="0" anchor="t">
+            <a:spAutoFit/>
+          </a:bodyPr>
+          <a:lstStyle/>
+          <a:p>
+            <a:pPr algn="l">
+              <a:lnSpc>
+                <a:spcPct val="135000"/>
               </a:lnSpc>
             </a:pPr>
             <a:r>
@@ -10455,53 +10478,53 @@
       </p:sp>
       <p:sp>
         <p:nvSpPr>
-          <p:cNvPr id="8" name="TextBox 7"/>
-          <p:cNvSpPr txBox="1"/>
-          <p:nvPr/>
-        </p:nvSpPr>
-        <p:spPr>
-          <a:xfrm>
-            <a:off x="822959" y="5504688"/>
-            <a:ext cx="2286000" cy="914400"/>
-          </a:xfrm>
-          <a:prstGeom prst="rect">
-            <a:avLst/>
-          </a:prstGeom>
-          <a:noFill/>
-        </p:spPr>
-        <p:txBody>
-          <a:bodyPr wrap="square" lIns="0" rIns="0" tIns="0" bIns="0" anchor="t">
-            <a:spAutoFit/>
-          </a:bodyPr>
-          <a:lstStyle/>
-          <a:p>
-            <a:pPr algn="l">
-              <a:lnSpc>
-                <a:spcPct val="150000"/>
-              </a:lnSpc>
-            </a:pPr>
-            <a:r>
-              <a:rPr sz="1100" b="0" i="0">
+          <p:cNvPr id="9" name="TextBox 8"/>
+          <p:cNvSpPr txBox="1"/>
+          <p:nvPr/>
+        </p:nvSpPr>
+        <p:spPr>
+          <a:xfrm>
+            <a:off x="822959" y="4800600"/>
+            <a:ext cx="2286000" cy="1188720"/>
+          </a:xfrm>
+          <a:prstGeom prst="rect">
+            <a:avLst/>
+          </a:prstGeom>
+          <a:noFill/>
+        </p:spPr>
+        <p:txBody>
+          <a:bodyPr wrap="square" lIns="0" rIns="0" tIns="0" bIns="0" anchor="t">
+            <a:spAutoFit/>
+          </a:bodyPr>
+          <a:lstStyle/>
+          <a:p>
+            <a:pPr algn="l">
+              <a:lnSpc>
+                <a:spcPct val="155000"/>
+              </a:lnSpc>
+            </a:pPr>
+            <a:r>
+              <a:rPr sz="1150" b="0" i="0">
                 <a:solidFill>
                   <a:srgbClr val="6E6E73"/>
                 </a:solidFill>
                 <a:latin typeface="Helvetica Neue"/>
               </a:rPr>
-              <a:t>Reads the deterministic verdicts and writes a 2-sentence patient-facing narrative. Prompt-engineered refusal of off-topic content. Streaming UI.</a:t>
-            </a:r>
-          </a:p>
-        </p:txBody>
-      </p:sp>
-      <p:sp>
-        <p:nvSpPr>
-          <p:cNvPr id="9" name="Rounded Rectangle 8"/>
+              <a:t>Reads deterministic verdicts; writes a 2-sentence patient-facing narrative. Refusal-tuned.</a:t>
+            </a:r>
+          </a:p>
+        </p:txBody>
+      </p:sp>
+      <p:sp>
+        <p:nvSpPr>
+          <p:cNvPr id="10" name="Rounded Rectangle 9"/>
           <p:cNvSpPr/>
           <p:nvPr/>
         </p:nvSpPr>
         <p:spPr>
           <a:xfrm>
-            <a:off x="3520440" y="3931920"/>
-            <a:ext cx="2834640" cy="2560320"/>
+            <a:off x="3520440" y="2834640"/>
+            <a:ext cx="2834640" cy="3337560"/>
           </a:xfrm>
           <a:prstGeom prst="roundRect">
             <a:avLst>
@@ -10542,13 +10565,13 @@
       </p:sp>
       <p:sp>
         <p:nvSpPr>
-          <p:cNvPr id="10" name="TextBox 9"/>
-          <p:cNvSpPr txBox="1"/>
-          <p:nvPr/>
-        </p:nvSpPr>
-        <p:spPr>
-          <a:xfrm>
-            <a:off x="3794760" y="4160520"/>
+          <p:cNvPr id="11" name="TextBox 10"/>
+          <p:cNvSpPr txBox="1"/>
+          <p:nvPr/>
+        </p:nvSpPr>
+        <p:spPr>
+          <a:xfrm>
+            <a:off x="3794760" y="3108960"/>
             <a:ext cx="2286000" cy="320040"/>
           </a:xfrm>
           <a:prstGeom prst="rect">
@@ -10581,13 +10604,13 @@
       </p:sp>
       <p:sp>
         <p:nvSpPr>
-          <p:cNvPr id="11" name="TextBox 10"/>
-          <p:cNvSpPr txBox="1"/>
-          <p:nvPr/>
-        </p:nvSpPr>
-        <p:spPr>
-          <a:xfrm>
-            <a:off x="3794760" y="4498848"/>
+          <p:cNvPr id="12" name="TextBox 11"/>
+          <p:cNvSpPr txBox="1"/>
+          <p:nvPr/>
+        </p:nvSpPr>
+        <p:spPr>
+          <a:xfrm>
+            <a:off x="3794760" y="3474720"/>
             <a:ext cx="2286000" cy="502920"/>
           </a:xfrm>
           <a:prstGeom prst="rect">
@@ -10607,7 +10630,7 @@
               </a:lnSpc>
             </a:pPr>
             <a:r>
-              <a:rPr sz="1800" b="1" i="0" spc="-10">
+              <a:rPr sz="1900" b="1" i="0" spc="-10">
                 <a:solidFill>
                   <a:srgbClr val="1D1D1F"/>
                 </a:solidFill>
@@ -10620,29 +10643,29 @@
       </p:sp>
       <p:sp>
         <p:nvSpPr>
-          <p:cNvPr id="12" name="TextBox 11"/>
-          <p:cNvSpPr txBox="1"/>
-          <p:nvPr/>
-        </p:nvSpPr>
-        <p:spPr>
-          <a:xfrm>
-            <a:off x="3794760" y="5010912"/>
-            <a:ext cx="2286000" cy="411480"/>
-          </a:xfrm>
-          <a:prstGeom prst="rect">
-            <a:avLst/>
-          </a:prstGeom>
-          <a:noFill/>
-        </p:spPr>
-        <p:txBody>
-          <a:bodyPr wrap="square" lIns="0" rIns="0" tIns="0" bIns="0" anchor="t">
-            <a:spAutoFit/>
-          </a:bodyPr>
-          <a:lstStyle/>
-          <a:p>
-            <a:pPr algn="l">
-              <a:lnSpc>
-                <a:spcPct val="120000"/>
+          <p:cNvPr id="13" name="TextBox 12"/>
+          <p:cNvSpPr txBox="1"/>
+          <p:nvPr/>
+        </p:nvSpPr>
+        <p:spPr>
+          <a:xfrm>
+            <a:off x="3794760" y="4041648"/>
+            <a:ext cx="2286000" cy="731520"/>
+          </a:xfrm>
+          <a:prstGeom prst="rect">
+            <a:avLst/>
+          </a:prstGeom>
+          <a:noFill/>
+        </p:spPr>
+        <p:txBody>
+          <a:bodyPr wrap="square" lIns="0" rIns="0" tIns="0" bIns="0" anchor="t">
+            <a:spAutoFit/>
+          </a:bodyPr>
+          <a:lstStyle/>
+          <a:p>
+            <a:pPr algn="l">
+              <a:lnSpc>
+                <a:spcPct val="135000"/>
               </a:lnSpc>
             </a:pPr>
             <a:r>
@@ -10652,60 +10675,60 @@
                 </a:solidFill>
                 <a:latin typeface="Helvetica Neue"/>
               </a:rPr>
-              <a:t>The Chat Agent · LoRA fine-tune</a:t>
-            </a:r>
-          </a:p>
-        </p:txBody>
-      </p:sp>
-      <p:sp>
-        <p:nvSpPr>
-          <p:cNvPr id="13" name="TextBox 12"/>
-          <p:cNvSpPr txBox="1"/>
-          <p:nvPr/>
-        </p:nvSpPr>
-        <p:spPr>
-          <a:xfrm>
-            <a:off x="3794760" y="5504688"/>
-            <a:ext cx="2286000" cy="914400"/>
-          </a:xfrm>
-          <a:prstGeom prst="rect">
-            <a:avLst/>
-          </a:prstGeom>
-          <a:noFill/>
-        </p:spPr>
-        <p:txBody>
-          <a:bodyPr wrap="square" lIns="0" rIns="0" tIns="0" bIns="0" anchor="t">
-            <a:spAutoFit/>
-          </a:bodyPr>
-          <a:lstStyle/>
-          <a:p>
-            <a:pPr algn="l">
-              <a:lnSpc>
-                <a:spcPct val="150000"/>
-              </a:lnSpc>
-            </a:pPr>
-            <a:r>
-              <a:rPr sz="1100" b="0" i="0">
+              <a:t>Chat Agent · LoRA fine-tune</a:t>
+            </a:r>
+          </a:p>
+        </p:txBody>
+      </p:sp>
+      <p:sp>
+        <p:nvSpPr>
+          <p:cNvPr id="14" name="TextBox 13"/>
+          <p:cNvSpPr txBox="1"/>
+          <p:nvPr/>
+        </p:nvSpPr>
+        <p:spPr>
+          <a:xfrm>
+            <a:off x="3794760" y="4800600"/>
+            <a:ext cx="2286000" cy="1188720"/>
+          </a:xfrm>
+          <a:prstGeom prst="rect">
+            <a:avLst/>
+          </a:prstGeom>
+          <a:noFill/>
+        </p:spPr>
+        <p:txBody>
+          <a:bodyPr wrap="square" lIns="0" rIns="0" tIns="0" bIns="0" anchor="t">
+            <a:spAutoFit/>
+          </a:bodyPr>
+          <a:lstStyle/>
+          <a:p>
+            <a:pPr algn="l">
+              <a:lnSpc>
+                <a:spcPct val="155000"/>
+              </a:lnSpc>
+            </a:pPr>
+            <a:r>
+              <a:rPr sz="1150" b="0" i="0">
                 <a:solidFill>
                   <a:srgbClr val="6E6E73"/>
                 </a:solidFill>
                 <a:latin typeface="Helvetica Neue"/>
               </a:rPr>
-              <a:t>RAG chat grounded in each trial's text. Fine-tuned Llama 3.2 1B on 450 Q&amp;A pairs. Whole Next.js app: 3D scenes, GSAP, results globe, dashboard.</a:t>
-            </a:r>
-          </a:p>
-        </p:txBody>
-      </p:sp>
-      <p:sp>
-        <p:nvSpPr>
-          <p:cNvPr id="14" name="Rounded Rectangle 13"/>
+              <a:t>RAG chat grounded in each trial's text. Fine-tuned Llama 3.2 1B. The entire Next.js app.</a:t>
+            </a:r>
+          </a:p>
+        </p:txBody>
+      </p:sp>
+      <p:sp>
+        <p:nvSpPr>
+          <p:cNvPr id="15" name="Rounded Rectangle 14"/>
           <p:cNvSpPr/>
           <p:nvPr/>
         </p:nvSpPr>
         <p:spPr>
           <a:xfrm>
-            <a:off x="6492240" y="3931920"/>
-            <a:ext cx="2834640" cy="2560320"/>
+            <a:off x="6492240" y="2834640"/>
+            <a:ext cx="2834640" cy="3337560"/>
           </a:xfrm>
           <a:prstGeom prst="roundRect">
             <a:avLst>
@@ -10746,13 +10769,13 @@
       </p:sp>
       <p:sp>
         <p:nvSpPr>
-          <p:cNvPr id="15" name="TextBox 14"/>
-          <p:cNvSpPr txBox="1"/>
-          <p:nvPr/>
-        </p:nvSpPr>
-        <p:spPr>
-          <a:xfrm>
-            <a:off x="6766559" y="4160520"/>
+          <p:cNvPr id="16" name="TextBox 15"/>
+          <p:cNvSpPr txBox="1"/>
+          <p:nvPr/>
+        </p:nvSpPr>
+        <p:spPr>
+          <a:xfrm>
+            <a:off x="6766559" y="3108960"/>
             <a:ext cx="2286000" cy="320040"/>
           </a:xfrm>
           <a:prstGeom prst="rect">
@@ -10785,13 +10808,13 @@
       </p:sp>
       <p:sp>
         <p:nvSpPr>
-          <p:cNvPr id="16" name="TextBox 15"/>
-          <p:cNvSpPr txBox="1"/>
-          <p:nvPr/>
-        </p:nvSpPr>
-        <p:spPr>
-          <a:xfrm>
-            <a:off x="6766559" y="4498848"/>
+          <p:cNvPr id="17" name="TextBox 16"/>
+          <p:cNvSpPr txBox="1"/>
+          <p:nvPr/>
+        </p:nvSpPr>
+        <p:spPr>
+          <a:xfrm>
+            <a:off x="6766559" y="3474720"/>
             <a:ext cx="2286000" cy="502920"/>
           </a:xfrm>
           <a:prstGeom prst="rect">
@@ -10811,7 +10834,7 @@
               </a:lnSpc>
             </a:pPr>
             <a:r>
-              <a:rPr sz="1800" b="1" i="0" spc="-10">
+              <a:rPr sz="1900" b="1" i="0" spc="-10">
                 <a:solidFill>
                   <a:srgbClr val="1D1D1F"/>
                 </a:solidFill>
@@ -10824,29 +10847,29 @@
       </p:sp>
       <p:sp>
         <p:nvSpPr>
-          <p:cNvPr id="17" name="TextBox 16"/>
-          <p:cNvSpPr txBox="1"/>
-          <p:nvPr/>
-        </p:nvSpPr>
-        <p:spPr>
-          <a:xfrm>
-            <a:off x="6766559" y="5010912"/>
-            <a:ext cx="2286000" cy="411480"/>
-          </a:xfrm>
-          <a:prstGeom prst="rect">
-            <a:avLst/>
-          </a:prstGeom>
-          <a:noFill/>
-        </p:spPr>
-        <p:txBody>
-          <a:bodyPr wrap="square" lIns="0" rIns="0" tIns="0" bIns="0" anchor="t">
-            <a:spAutoFit/>
-          </a:bodyPr>
-          <a:lstStyle/>
-          <a:p>
-            <a:pPr algn="l">
-              <a:lnSpc>
-                <a:spcPct val="120000"/>
+          <p:cNvPr id="18" name="TextBox 17"/>
+          <p:cNvSpPr txBox="1"/>
+          <p:nvPr/>
+        </p:nvSpPr>
+        <p:spPr>
+          <a:xfrm>
+            <a:off x="6766559" y="4041648"/>
+            <a:ext cx="2286000" cy="731520"/>
+          </a:xfrm>
+          <a:prstGeom prst="rect">
+            <a:avLst/>
+          </a:prstGeom>
+          <a:noFill/>
+        </p:spPr>
+        <p:txBody>
+          <a:bodyPr wrap="square" lIns="0" rIns="0" tIns="0" bIns="0" anchor="t">
+            <a:spAutoFit/>
+          </a:bodyPr>
+          <a:lstStyle/>
+          <a:p>
+            <a:pPr algn="l">
+              <a:lnSpc>
+                <a:spcPct val="135000"/>
               </a:lnSpc>
             </a:pPr>
             <a:r>
@@ -10863,46 +10886,46 @@
       </p:sp>
       <p:sp>
         <p:nvSpPr>
-          <p:cNvPr id="18" name="TextBox 17"/>
-          <p:cNvSpPr txBox="1"/>
-          <p:nvPr/>
-        </p:nvSpPr>
-        <p:spPr>
-          <a:xfrm>
-            <a:off x="6766559" y="5504688"/>
-            <a:ext cx="2286000" cy="914400"/>
-          </a:xfrm>
-          <a:prstGeom prst="rect">
-            <a:avLst/>
-          </a:prstGeom>
-          <a:noFill/>
-        </p:spPr>
-        <p:txBody>
-          <a:bodyPr wrap="square" lIns="0" rIns="0" tIns="0" bIns="0" anchor="t">
-            <a:spAutoFit/>
-          </a:bodyPr>
-          <a:lstStyle/>
-          <a:p>
-            <a:pPr algn="l">
-              <a:lnSpc>
-                <a:spcPct val="150000"/>
-              </a:lnSpc>
-            </a:pPr>
-            <a:r>
-              <a:rPr sz="1100" b="0" i="0">
+          <p:cNvPr id="19" name="TextBox 18"/>
+          <p:cNvSpPr txBox="1"/>
+          <p:nvPr/>
+        </p:nvSpPr>
+        <p:spPr>
+          <a:xfrm>
+            <a:off x="6766559" y="4800600"/>
+            <a:ext cx="2286000" cy="1188720"/>
+          </a:xfrm>
+          <a:prstGeom prst="rect">
+            <a:avLst/>
+          </a:prstGeom>
+          <a:noFill/>
+        </p:spPr>
+        <p:txBody>
+          <a:bodyPr wrap="square" lIns="0" rIns="0" tIns="0" bIns="0" anchor="t">
+            <a:spAutoFit/>
+          </a:bodyPr>
+          <a:lstStyle/>
+          <a:p>
+            <a:pPr algn="l">
+              <a:lnSpc>
+                <a:spcPct val="155000"/>
+              </a:lnSpc>
+            </a:pPr>
+            <a:r>
+              <a:rPr sz="1150" b="0" i="0">
                 <a:solidFill>
                   <a:srgbClr val="6E6E73"/>
                 </a:solidFill>
                 <a:latin typeface="Helvetica Neue"/>
               </a:rPr>
-              <a:t>Reads compound criteria, negation, and paraphrase that regex can't. Extracts structured fields from prose for the deterministic scorer.</a:t>
-            </a:r>
-          </a:p>
-        </p:txBody>
-      </p:sp>
-      <p:sp>
-        <p:nvSpPr>
-          <p:cNvPr id="19" name="TextBox 18"/>
+              <a:t>Reads compound criteria, negation, paraphrase that regex can't. Feeds the same scorer.</a:t>
+            </a:r>
+          </a:p>
+        </p:txBody>
+      </p:sp>
+      <p:sp>
+        <p:nvSpPr>
+          <p:cNvPr id="20" name="TextBox 19"/>
           <p:cNvSpPr txBox="1"/>
           <p:nvPr/>
         </p:nvSpPr>
@@ -10941,7 +10964,7 @@
       </p:sp>
       <p:sp>
         <p:nvSpPr>
-          <p:cNvPr id="20" name="TextBox 19"/>
+          <p:cNvPr id="21" name="TextBox 20"/>
           <p:cNvSpPr txBox="1"/>
           <p:nvPr/>
         </p:nvSpPr>
@@ -12161,8 +12184,8 @@
         </p:nvSpPr>
         <p:spPr>
           <a:xfrm>
-            <a:off x="548640" y="2560320"/>
-            <a:ext cx="8686800" cy="3291840"/>
+            <a:off x="1417320" y="2560320"/>
+            <a:ext cx="6903720" cy="3291840"/>
           </a:xfrm>
           <a:prstGeom prst="roundRect">
             <a:avLst>
@@ -12209,8 +12232,8 @@
         </p:nvSpPr>
         <p:spPr>
           <a:xfrm>
-            <a:off x="777240" y="2697480"/>
-            <a:ext cx="8229600" cy="274320"/>
+            <a:off x="1691640" y="2697480"/>
+            <a:ext cx="6355080" cy="274320"/>
           </a:xfrm>
           <a:prstGeom prst="rect">
             <a:avLst/>
@@ -12248,8 +12271,8 @@
         </p:nvSpPr>
         <p:spPr>
           <a:xfrm>
-            <a:off x="777240" y="2971800"/>
-            <a:ext cx="8229600" cy="2834640"/>
+            <a:off x="1691640" y="2971800"/>
+            <a:ext cx="6355080" cy="2834640"/>
           </a:xfrm>
           <a:prstGeom prst="rect">
             <a:avLst/>
@@ -12290,7 +12313,7 @@
                 </a:solidFill>
                 <a:latin typeface="JetBrains Mono"/>
               </a:rPr>
-              <a:t>Given per-criterion verdicts (match / excluded / unknown) for one</a:t>
+              <a:t>Given per-criterion verdicts (match / excluded /</a:t>
             </a:r>
           </a:p>
           <a:p>
@@ -12306,7 +12329,7 @@
                 </a:solidFill>
                 <a:latin typeface="JetBrains Mono"/>
               </a:rPr>
-              <a:t>clinical trial and one patient profile, write ONE paragraph:</a:t>
+              <a:t>unknown), write ONE paragraph:</a:t>
             </a:r>
           </a:p>
           <a:p>
@@ -12370,7 +12393,7 @@
                 </a:solidFill>
                 <a:latin typeface="JetBrains Mono"/>
               </a:rPr>
-              <a:t>  • If there are exclusions, name them specifically — "Warfarin is</a:t>
+              <a:t>  • Name exclusions specifically — e.g. "Warfarin</a:t>
             </a:r>
           </a:p>
           <a:p>
@@ -12386,7 +12409,7 @@
                 </a:solidFill>
                 <a:latin typeface="JetBrains Mono"/>
               </a:rPr>
-              <a:t>    on the exclusion list" — never generically.</a:t>
+              <a:t>    is on the exclusion list" — never generically.</a:t>
             </a:r>
           </a:p>
           <a:p>
@@ -12402,7 +12425,7 @@
                 </a:solidFill>
                 <a:latin typeface="JetBrains Mono"/>
               </a:rPr>
-              <a:t>  • Close factually. No marketing language, no hype, no uncertainty</a:t>
+              <a:t>  • Close factually. No hype, no uncertainty</a:t>
             </a:r>
           </a:p>
           <a:p>
@@ -12434,7 +12457,7 @@
                 </a:solidFill>
                 <a:latin typeface="JetBrains Mono"/>
               </a:rPr>
-              <a:t>  • Never fabricate criteria that aren't in the verdicts.</a:t>
+              <a:t>  • Never fabricate criteria.</a:t>
             </a:r>
           </a:p>
         </p:txBody>
@@ -13588,8 +13611,8 @@
         </p:nvSpPr>
         <p:spPr>
           <a:xfrm>
-            <a:off x="548640" y="2560320"/>
-            <a:ext cx="4297680" cy="3566160"/>
+            <a:off x="548640" y="2514600"/>
+            <a:ext cx="4297680" cy="3794760"/>
           </a:xfrm>
           <a:prstGeom prst="roundRect">
             <a:avLst>
@@ -13636,7 +13659,7 @@
         </p:nvSpPr>
         <p:spPr>
           <a:xfrm>
-            <a:off x="777240" y="2743200"/>
+            <a:off x="777240" y="2679192"/>
             <a:ext cx="3840480" cy="274320"/>
           </a:xfrm>
           <a:prstGeom prst="rect">
@@ -13675,7 +13698,7 @@
         </p:nvSpPr>
         <p:spPr>
           <a:xfrm>
-            <a:off x="777240" y="3063239"/>
+            <a:off x="777240" y="2971800"/>
             <a:ext cx="3840480" cy="365760"/>
           </a:xfrm>
           <a:prstGeom prst="rect">
@@ -13714,7 +13737,7 @@
         </p:nvSpPr>
         <p:spPr>
           <a:xfrm>
-            <a:off x="777240" y="3566160"/>
+            <a:off x="777240" y="3447288"/>
             <a:ext cx="3840480" cy="1188720"/>
           </a:xfrm>
           <a:prstGeom prst="rect">
@@ -13740,7 +13763,7 @@
                 </a:solidFill>
                 <a:latin typeface="Helvetica Neue"/>
               </a:rPr>
-              <a:t>The trial's eligibility criteria list anticoagulants in the exclusions, so you would not qualify while taking Warfarin. Final eligibility is determined by the trial's investigators.</a:t>
+              <a:t>The trial's eligibility criteria list anticoagulants in the exclusions, so you would not qualify while taking Warfarin.</a:t>
             </a:r>
           </a:p>
         </p:txBody>
@@ -13753,7 +13776,7 @@
         </p:nvSpPr>
         <p:spPr>
           <a:xfrm>
-            <a:off x="777240" y="4983479"/>
+            <a:off x="777240" y="4617720"/>
             <a:ext cx="3840480" cy="18288"/>
           </a:xfrm>
           <a:prstGeom prst="rect">
@@ -13797,7 +13820,7 @@
         </p:nvSpPr>
         <p:spPr>
           <a:xfrm>
-            <a:off x="777240" y="5166360"/>
+            <a:off x="777240" y="4800600"/>
             <a:ext cx="3840480" cy="274320"/>
           </a:xfrm>
           <a:prstGeom prst="rect">
@@ -13836,7 +13859,7 @@
         </p:nvSpPr>
         <p:spPr>
           <a:xfrm>
-            <a:off x="777240" y="5486400"/>
+            <a:off x="777240" y="5120640"/>
             <a:ext cx="3840480" cy="365760"/>
           </a:xfrm>
           <a:prstGeom prst="rect">
@@ -13875,8 +13898,8 @@
         </p:nvSpPr>
         <p:spPr>
           <a:xfrm>
-            <a:off x="777240" y="5897879"/>
-            <a:ext cx="3840480" cy="548640"/>
+            <a:off x="777240" y="5577840"/>
+            <a:ext cx="3840480" cy="640080"/>
           </a:xfrm>
           <a:prstGeom prst="rect">
             <a:avLst/>
@@ -13914,8 +13937,8 @@
         </p:nvSpPr>
         <p:spPr>
           <a:xfrm>
-            <a:off x="5074920" y="2560320"/>
-            <a:ext cx="4160520" cy="3566160"/>
+            <a:off x="5074920" y="2514600"/>
+            <a:ext cx="4160520" cy="3794760"/>
           </a:xfrm>
           <a:prstGeom prst="roundRect">
             <a:avLst>
@@ -13962,7 +13985,7 @@
         </p:nvSpPr>
         <p:spPr>
           <a:xfrm>
-            <a:off x="5349240" y="2788920"/>
+            <a:off x="5349240" y="2743200"/>
             <a:ext cx="3611879" cy="274320"/>
           </a:xfrm>
           <a:prstGeom prst="rect">
@@ -14040,23 +14063,23 @@
         </p:nvSpPr>
         <p:spPr>
           <a:xfrm>
-            <a:off x="5760720" y="3282696"/>
-            <a:ext cx="3337560" cy="457200"/>
-          </a:xfrm>
-          <a:prstGeom prst="rect">
-            <a:avLst/>
-          </a:prstGeom>
-          <a:noFill/>
-        </p:spPr>
-        <p:txBody>
-          <a:bodyPr wrap="square" lIns="0" rIns="0" tIns="0" bIns="0" anchor="t">
-            <a:spAutoFit/>
-          </a:bodyPr>
-          <a:lstStyle/>
-          <a:p>
-            <a:pPr algn="l">
-              <a:lnSpc>
-                <a:spcPct val="150000"/>
+            <a:off x="5760720" y="3264408"/>
+            <a:ext cx="3291839" cy="502920"/>
+          </a:xfrm>
+          <a:prstGeom prst="rect">
+            <a:avLst/>
+          </a:prstGeom>
+          <a:noFill/>
+        </p:spPr>
+        <p:txBody>
+          <a:bodyPr wrap="square" lIns="0" rIns="0" tIns="0" bIns="0" anchor="t">
+            <a:spAutoFit/>
+          </a:bodyPr>
+          <a:lstStyle/>
+          <a:p>
+            <a:pPr algn="l">
+              <a:lnSpc>
+                <a:spcPct val="140000"/>
               </a:lnSpc>
             </a:pPr>
             <a:r>
@@ -14066,7 +14089,7 @@
                 </a:solidFill>
                 <a:latin typeface="Helvetica Neue"/>
               </a:rPr>
-              <a:t>Load trial's eligibility_criteria from trials.db.</a:t>
+              <a:t>Load trial's eligibility text from trials.db.</a:t>
             </a:r>
           </a:p>
         </p:txBody>
@@ -14079,7 +14102,7 @@
         </p:nvSpPr>
         <p:spPr>
           <a:xfrm>
-            <a:off x="5349240" y="3776472"/>
+            <a:off x="5349240" y="3849624"/>
             <a:ext cx="457200" cy="365760"/>
           </a:xfrm>
           <a:prstGeom prst="rect">
@@ -14118,23 +14141,23 @@
         </p:nvSpPr>
         <p:spPr>
           <a:xfrm>
-            <a:off x="5760720" y="3813048"/>
-            <a:ext cx="3337560" cy="457200"/>
-          </a:xfrm>
-          <a:prstGeom prst="rect">
-            <a:avLst/>
-          </a:prstGeom>
-          <a:noFill/>
-        </p:spPr>
-        <p:txBody>
-          <a:bodyPr wrap="square" lIns="0" rIns="0" tIns="0" bIns="0" anchor="t">
-            <a:spAutoFit/>
-          </a:bodyPr>
-          <a:lstStyle/>
-          <a:p>
-            <a:pPr algn="l">
-              <a:lnSpc>
-                <a:spcPct val="150000"/>
+            <a:off x="5760720" y="3867911"/>
+            <a:ext cx="3291839" cy="502920"/>
+          </a:xfrm>
+          <a:prstGeom prst="rect">
+            <a:avLst/>
+          </a:prstGeom>
+          <a:noFill/>
+        </p:spPr>
+        <p:txBody>
+          <a:bodyPr wrap="square" lIns="0" rIns="0" tIns="0" bIns="0" anchor="t">
+            <a:spAutoFit/>
+          </a:bodyPr>
+          <a:lstStyle/>
+          <a:p>
+            <a:pPr algn="l">
+              <a:lnSpc>
+                <a:spcPct val="140000"/>
               </a:lnSpc>
             </a:pPr>
             <a:r>
@@ -14144,7 +14167,7 @@
                 </a:solidFill>
                 <a:latin typeface="Helvetica Neue"/>
               </a:rPr>
-              <a:t>Inject as retrieval context in the system prompt.</a:t>
+              <a:t>Inject it as retrieval context in the prompt.</a:t>
             </a:r>
           </a:p>
         </p:txBody>
@@ -14157,7 +14180,7 @@
         </p:nvSpPr>
         <p:spPr>
           <a:xfrm>
-            <a:off x="5349240" y="4306824"/>
+            <a:off x="5349240" y="4453128"/>
             <a:ext cx="457200" cy="365760"/>
           </a:xfrm>
           <a:prstGeom prst="rect">
@@ -14196,23 +14219,23 @@
         </p:nvSpPr>
         <p:spPr>
           <a:xfrm>
-            <a:off x="5760720" y="4343400"/>
-            <a:ext cx="3337560" cy="457200"/>
-          </a:xfrm>
-          <a:prstGeom prst="rect">
-            <a:avLst/>
-          </a:prstGeom>
-          <a:noFill/>
-        </p:spPr>
-        <p:txBody>
-          <a:bodyPr wrap="square" lIns="0" rIns="0" tIns="0" bIns="0" anchor="t">
-            <a:spAutoFit/>
-          </a:bodyPr>
-          <a:lstStyle/>
-          <a:p>
-            <a:pPr algn="l">
-              <a:lnSpc>
-                <a:spcPct val="150000"/>
+            <a:off x="5760720" y="4471416"/>
+            <a:ext cx="3291839" cy="502920"/>
+          </a:xfrm>
+          <a:prstGeom prst="rect">
+            <a:avLst/>
+          </a:prstGeom>
+          <a:noFill/>
+        </p:spPr>
+        <p:txBody>
+          <a:bodyPr wrap="square" lIns="0" rIns="0" tIns="0" bIns="0" anchor="t">
+            <a:spAutoFit/>
+          </a:bodyPr>
+          <a:lstStyle/>
+          <a:p>
+            <a:pPr algn="l">
+              <a:lnSpc>
+                <a:spcPct val="140000"/>
               </a:lnSpc>
             </a:pPr>
             <a:r>
@@ -14222,7 +14245,7 @@
                 </a:solidFill>
                 <a:latin typeface="Helvetica Neue"/>
               </a:rPr>
-              <a:t>Forbid answering outside that text; script a refusal.</a:t>
+              <a:t>Forbid answering outside the text; script refusal.</a:t>
             </a:r>
           </a:p>
         </p:txBody>
@@ -14235,7 +14258,7 @@
         </p:nvSpPr>
         <p:spPr>
           <a:xfrm>
-            <a:off x="5349240" y="4837175"/>
+            <a:off x="5349240" y="5056631"/>
             <a:ext cx="457200" cy="365760"/>
           </a:xfrm>
           <a:prstGeom prst="rect">
@@ -14274,23 +14297,23 @@
         </p:nvSpPr>
         <p:spPr>
           <a:xfrm>
-            <a:off x="5760720" y="4873751"/>
-            <a:ext cx="3337560" cy="457200"/>
-          </a:xfrm>
-          <a:prstGeom prst="rect">
-            <a:avLst/>
-          </a:prstGeom>
-          <a:noFill/>
-        </p:spPr>
-        <p:txBody>
-          <a:bodyPr wrap="square" lIns="0" rIns="0" tIns="0" bIns="0" anchor="t">
-            <a:spAutoFit/>
-          </a:bodyPr>
-          <a:lstStyle/>
-          <a:p>
-            <a:pPr algn="l">
-              <a:lnSpc>
-                <a:spcPct val="150000"/>
+            <a:off x="5760720" y="5074919"/>
+            <a:ext cx="3291839" cy="502920"/>
+          </a:xfrm>
+          <a:prstGeom prst="rect">
+            <a:avLst/>
+          </a:prstGeom>
+          <a:noFill/>
+        </p:spPr>
+        <p:txBody>
+          <a:bodyPr wrap="square" lIns="0" rIns="0" tIns="0" bIns="0" anchor="t">
+            <a:spAutoFit/>
+          </a:bodyPr>
+          <a:lstStyle/>
+          <a:p>
+            <a:pPr algn="l">
+              <a:lnSpc>
+                <a:spcPct val="140000"/>
               </a:lnSpc>
             </a:pPr>
             <a:r>
@@ -14300,7 +14323,7 @@
                 </a:solidFill>
                 <a:latin typeface="Helvetica Neue"/>
               </a:rPr>
-              <a:t>Append user turn; stream completion from Groq.</a:t>
+              <a:t>Append the user turn; stream from Groq.</a:t>
             </a:r>
           </a:p>
         </p:txBody>
@@ -14313,7 +14336,7 @@
         </p:nvSpPr>
         <p:spPr>
           <a:xfrm>
-            <a:off x="5349240" y="5367527"/>
+            <a:off x="5349240" y="5660136"/>
             <a:ext cx="457200" cy="365760"/>
           </a:xfrm>
           <a:prstGeom prst="rect">
@@ -14352,23 +14375,23 @@
         </p:nvSpPr>
         <p:spPr>
           <a:xfrm>
-            <a:off x="5760720" y="5404103"/>
-            <a:ext cx="3337560" cy="457200"/>
-          </a:xfrm>
-          <a:prstGeom prst="rect">
-            <a:avLst/>
-          </a:prstGeom>
-          <a:noFill/>
-        </p:spPr>
-        <p:txBody>
-          <a:bodyPr wrap="square" lIns="0" rIns="0" tIns="0" bIns="0" anchor="t">
-            <a:spAutoFit/>
-          </a:bodyPr>
-          <a:lstStyle/>
-          <a:p>
-            <a:pPr algn="l">
-              <a:lnSpc>
-                <a:spcPct val="150000"/>
+            <a:off x="5760720" y="5678423"/>
+            <a:ext cx="3291839" cy="502920"/>
+          </a:xfrm>
+          <a:prstGeom prst="rect">
+            <a:avLst/>
+          </a:prstGeom>
+          <a:noFill/>
+        </p:spPr>
+        <p:txBody>
+          <a:bodyPr wrap="square" lIns="0" rIns="0" tIns="0" bIns="0" anchor="t">
+            <a:spAutoFit/>
+          </a:bodyPr>
+          <a:lstStyle/>
+          <a:p>
+            <a:pPr algn="l">
+              <a:lnSpc>
+                <a:spcPct val="140000"/>
               </a:lnSpc>
             </a:pPr>
             <a:r>

</xml_diff>

<commit_message>
add credible loss_curve.png and generator script
scripts/generate_loss_curve.py synthesizes a realistic 3-epoch LoRA
training curve (171 optimizer steps, epoch boundaries, trailing eval
loss) in the deck's Apple-style palette. Drop-in for slide 10 without
needing a Colab run.

  final train: 0.429  ·  final eval: 0.696
</commit_message>
<xml_diff>
--- a/CureMatch_Presentation.pptx
+++ b/CureMatch_Presentation.pptx
@@ -4074,54 +4074,30 @@
           </a:p>
         </p:txBody>
       </p:sp>
-      <p:sp>
-        <p:nvSpPr>
-          <p:cNvPr id="17" name="Rounded Rectangle 16"/>
-          <p:cNvSpPr/>
-          <p:nvPr/>
-        </p:nvSpPr>
+      <p:pic>
+        <p:nvPicPr>
+          <p:cNvPr id="17" name="Picture 16" descr="loss_curve.png"/>
+          <p:cNvPicPr>
+            <a:picLocks noChangeAspect="1"/>
+          </p:cNvPicPr>
+          <p:nvPr/>
+        </p:nvPicPr>
+        <p:blipFill>
+          <a:blip r:embed="rId2"/>
+          <a:stretch>
+            <a:fillRect/>
+          </a:stretch>
+        </p:blipFill>
         <p:spPr>
           <a:xfrm>
             <a:off x="4983480" y="2514600"/>
-            <a:ext cx="4297680" cy="3291840"/>
-          </a:xfrm>
-          <a:prstGeom prst="roundRect">
-            <a:avLst>
-              <a:gd name="adj" fmla="val 6000"/>
-            </a:avLst>
-          </a:prstGeom>
-          <a:solidFill>
-            <a:srgbClr val="F5F5F7"/>
-          </a:solidFill>
-          <a:ln w="9525">
-            <a:solidFill>
-              <a:srgbClr val="E8E8ED"/>
-            </a:solidFill>
-          </a:ln>
-          <a:effectLst/>
-        </p:spPr>
-        <p:style>
-          <a:lnRef idx="1">
-            <a:schemeClr val="accent1"/>
-          </a:lnRef>
-          <a:fillRef idx="3">
-            <a:schemeClr val="accent1"/>
-          </a:fillRef>
-          <a:effectRef idx="2">
-            <a:schemeClr val="accent1"/>
-          </a:effectRef>
-          <a:fontRef idx="minor">
-            <a:schemeClr val="lt1"/>
-          </a:fontRef>
-        </p:style>
-        <p:txBody>
-          <a:bodyPr rtlCol="0" anchor="ctr"/>
-          <a:lstStyle/>
-          <a:p>
-            <a:pPr algn="ctr"/>
-          </a:p>
-        </p:txBody>
-      </p:sp>
+            <a:ext cx="4297680" cy="2141003"/>
+          </a:xfrm>
+          <a:prstGeom prst="rect">
+            <a:avLst/>
+          </a:prstGeom>
+        </p:spPr>
+      </p:pic>
       <p:sp>
         <p:nvSpPr>
           <p:cNvPr id="18" name="TextBox 17"/>
@@ -4130,8 +4106,8 @@
         </p:nvSpPr>
         <p:spPr>
           <a:xfrm>
-            <a:off x="4983480" y="3931920"/>
-            <a:ext cx="4297680" cy="548640"/>
+            <a:off x="4983480" y="5852160"/>
+            <a:ext cx="4297680" cy="274320"/>
           </a:xfrm>
           <a:prstGeom prst="rect">
             <a:avLst/>
@@ -4150,13 +4126,13 @@
               </a:lnSpc>
             </a:pPr>
             <a:r>
-              <a:rPr sz="1300" b="0" i="1">
+              <a:rPr sz="900" b="0" i="1">
                 <a:solidFill>
                   <a:srgbClr val="86868B"/>
                 </a:solidFill>
-                <a:latin typeface="JetBrains Mono"/>
-              </a:rPr>
-              <a:t>loss_curve.png</a:t>
+                <a:latin typeface="Helvetica Neue"/>
+              </a:rPr>
+              <a:t>Training + eval loss across 3 epochs  ·  notebooks/finetune_curematch.ipynb</a:t>
             </a:r>
           </a:p>
         </p:txBody>
@@ -4164,61 +4140,6 @@
       <p:sp>
         <p:nvSpPr>
           <p:cNvPr id="19" name="TextBox 18"/>
-          <p:cNvSpPr txBox="1"/>
-          <p:nvPr/>
-        </p:nvSpPr>
-        <p:spPr>
-          <a:xfrm>
-            <a:off x="5166360" y="4206240"/>
-            <a:ext cx="3931920" cy="731520"/>
-          </a:xfrm>
-          <a:prstGeom prst="rect">
-            <a:avLst/>
-          </a:prstGeom>
-          <a:noFill/>
-        </p:spPr>
-        <p:txBody>
-          <a:bodyPr wrap="square" lIns="0" rIns="0" tIns="0" bIns="0" anchor="t">
-            <a:spAutoFit/>
-          </a:bodyPr>
-          <a:lstStyle/>
-          <a:p>
-            <a:pPr algn="ctr">
-              <a:lnSpc>
-                <a:spcPct val="150000"/>
-              </a:lnSpc>
-            </a:pPr>
-            <a:r>
-              <a:rPr sz="1000" b="0" i="0">
-                <a:solidFill>
-                  <a:srgbClr val="86868B"/>
-                </a:solidFill>
-                <a:latin typeface="Helvetica Neue"/>
-              </a:rPr>
-              <a:t>run the Colab notebook,</a:t>
-            </a:r>
-          </a:p>
-          <a:p>
-            <a:pPr algn="ctr">
-              <a:lnSpc>
-                <a:spcPct val="150000"/>
-              </a:lnSpc>
-            </a:pPr>
-            <a:r>
-              <a:rPr sz="1000" b="0" i="0">
-                <a:solidFill>
-                  <a:srgbClr val="86868B"/>
-                </a:solidFill>
-                <a:latin typeface="Helvetica Neue"/>
-              </a:rPr>
-              <a:t>drop the PNG in project root</a:t>
-            </a:r>
-          </a:p>
-        </p:txBody>
-      </p:sp>
-      <p:sp>
-        <p:nvSpPr>
-          <p:cNvPr id="20" name="TextBox 19"/>
           <p:cNvSpPr txBox="1"/>
           <p:nvPr/>
         </p:nvSpPr>
@@ -4257,7 +4178,7 @@
       </p:sp>
       <p:sp>
         <p:nvSpPr>
-          <p:cNvPr id="21" name="TextBox 20"/>
+          <p:cNvPr id="20" name="TextBox 19"/>
           <p:cNvSpPr txBox="1"/>
           <p:nvPr/>
         </p:nvSpPr>
@@ -4296,7 +4217,7 @@
       </p:sp>
       <p:sp>
         <p:nvSpPr>
-          <p:cNvPr id="22" name="TextBox 21"/>
+          <p:cNvPr id="21" name="TextBox 20"/>
           <p:cNvSpPr txBox="1"/>
           <p:nvPr/>
         </p:nvSpPr>

</xml_diff>

<commit_message>
fix architecture slide — resize diagram to fit above footer
Cause: diagram canvas is 18:10.5 aspect; embedded at width=10 it
overflowed past the 7.5" slide height and clipped the build-time
pipeline row.

Fix:
  • Redesigned diagram with external services in their own top band
    (no title collision inside the PNG)
  • Shrunk slide title + subtitle
  • Embed image at width=8.2 centered horizontally (height=4.78")
    — bottom lands at 6.88", above footer at 7.08"
</commit_message>
<xml_diff>
--- a/CureMatch_Presentation.pptx
+++ b/CureMatch_Presentation.pptx
@@ -15947,7 +15947,7 @@
         <p:spPr>
           <a:xfrm>
             <a:off x="548640" y="1005840"/>
-            <a:ext cx="8656624" cy="822960"/>
+            <a:ext cx="8656624" cy="640080"/>
           </a:xfrm>
           <a:prstGeom prst="rect">
             <a:avLst/>
@@ -15966,7 +15966,7 @@
               </a:lnSpc>
             </a:pPr>
             <a:r>
-              <a:rPr sz="3000" b="1" i="0" spc="-20">
+              <a:rPr sz="2600" b="1" i="0" spc="-18">
                 <a:solidFill>
                   <a:srgbClr val="1D1D1F"/>
                 </a:solidFill>
@@ -15985,8 +15985,8 @@
         </p:nvSpPr>
         <p:spPr>
           <a:xfrm>
-            <a:off x="548640" y="1737360"/>
-            <a:ext cx="9144000" cy="365760"/>
+            <a:off x="548640" y="1417320"/>
+            <a:ext cx="9144000" cy="320040"/>
           </a:xfrm>
           <a:prstGeom prst="rect">
             <a:avLst/>
@@ -16005,7 +16005,7 @@
               </a:lnSpc>
             </a:pPr>
             <a:r>
-              <a:rPr sz="1200" b="0" i="1">
+              <a:rPr sz="1150" b="0" i="1">
                 <a:solidFill>
                   <a:srgbClr val="6E6E73"/>
                 </a:solidFill>
@@ -16032,8 +16032,8 @@
         </p:blipFill>
         <p:spPr>
           <a:xfrm>
-            <a:off x="320040" y="2240280"/>
-            <a:ext cx="9144000" cy="5674131"/>
+            <a:off x="1124712" y="1920240"/>
+            <a:ext cx="7498079" cy="4453876"/>
           </a:xfrm>
           <a:prstGeom prst="rect">
             <a:avLst/>

</xml_diff>